<commit_message>
Changes after Email Reports and Email Remiders have been fixed
</commit_message>
<xml_diff>
--- a/VanaraFleetsOps_Improvements.pptx
+++ b/VanaraFleetsOps_Improvements.pptx
@@ -7,7 +7,9 @@
   <p:sldIdLst>
     <p:sldId id="256" r:id="rId2"/>
     <p:sldId id="257" r:id="rId3"/>
-    <p:sldId id="258" r:id="rId4"/>
+    <p:sldId id="263" r:id="rId4"/>
+    <p:sldId id="258" r:id="rId5"/>
+    <p:sldId id="264" r:id="rId6"/>
   </p:sldIdLst>
   <p:sldSz cx="12192000" cy="6858000"/>
   <p:notesSz cx="6858000" cy="9144000"/>
@@ -106,6 +108,11 @@
       </a:defRPr>
     </a:lvl9pPr>
   </p:defaultTextStyle>
+  <p:extLst>
+    <p:ext uri="{EFAFB233-063F-42B5-8137-9DF3F51BA10A}">
+      <p15:sldGuideLst xmlns:p15="http://schemas.microsoft.com/office/powerpoint/2012/main"/>
+    </p:ext>
+  </p:extLst>
 </p:presentation>
 </file>
 
@@ -258,7 +265,7 @@
           <a:p>
             <a:fld id="{908607B5-E60D-4B4E-A941-993B6DE6A7EA}" type="datetimeFigureOut">
               <a:rPr lang="en-NG" smtClean="0"/>
-              <a:t>04/05/2026</a:t>
+              <a:t>12/05/2026</a:t>
             </a:fld>
             <a:endParaRPr lang="en-NG"/>
           </a:p>
@@ -458,7 +465,7 @@
           <a:p>
             <a:fld id="{908607B5-E60D-4B4E-A941-993B6DE6A7EA}" type="datetimeFigureOut">
               <a:rPr lang="en-NG" smtClean="0"/>
-              <a:t>04/05/2026</a:t>
+              <a:t>12/05/2026</a:t>
             </a:fld>
             <a:endParaRPr lang="en-NG"/>
           </a:p>
@@ -668,7 +675,7 @@
           <a:p>
             <a:fld id="{908607B5-E60D-4B4E-A941-993B6DE6A7EA}" type="datetimeFigureOut">
               <a:rPr lang="en-NG" smtClean="0"/>
-              <a:t>04/05/2026</a:t>
+              <a:t>12/05/2026</a:t>
             </a:fld>
             <a:endParaRPr lang="en-NG"/>
           </a:p>
@@ -868,7 +875,7 @@
           <a:p>
             <a:fld id="{908607B5-E60D-4B4E-A941-993B6DE6A7EA}" type="datetimeFigureOut">
               <a:rPr lang="en-NG" smtClean="0"/>
-              <a:t>04/05/2026</a:t>
+              <a:t>12/05/2026</a:t>
             </a:fld>
             <a:endParaRPr lang="en-NG"/>
           </a:p>
@@ -1144,7 +1151,7 @@
           <a:p>
             <a:fld id="{908607B5-E60D-4B4E-A941-993B6DE6A7EA}" type="datetimeFigureOut">
               <a:rPr lang="en-NG" smtClean="0"/>
-              <a:t>04/05/2026</a:t>
+              <a:t>12/05/2026</a:t>
             </a:fld>
             <a:endParaRPr lang="en-NG"/>
           </a:p>
@@ -1412,7 +1419,7 @@
           <a:p>
             <a:fld id="{908607B5-E60D-4B4E-A941-993B6DE6A7EA}" type="datetimeFigureOut">
               <a:rPr lang="en-NG" smtClean="0"/>
-              <a:t>04/05/2026</a:t>
+              <a:t>12/05/2026</a:t>
             </a:fld>
             <a:endParaRPr lang="en-NG"/>
           </a:p>
@@ -1827,7 +1834,7 @@
           <a:p>
             <a:fld id="{908607B5-E60D-4B4E-A941-993B6DE6A7EA}" type="datetimeFigureOut">
               <a:rPr lang="en-NG" smtClean="0"/>
-              <a:t>04/05/2026</a:t>
+              <a:t>12/05/2026</a:t>
             </a:fld>
             <a:endParaRPr lang="en-NG"/>
           </a:p>
@@ -1969,7 +1976,7 @@
           <a:p>
             <a:fld id="{908607B5-E60D-4B4E-A941-993B6DE6A7EA}" type="datetimeFigureOut">
               <a:rPr lang="en-NG" smtClean="0"/>
-              <a:t>04/05/2026</a:t>
+              <a:t>12/05/2026</a:t>
             </a:fld>
             <a:endParaRPr lang="en-NG"/>
           </a:p>
@@ -2082,7 +2089,7 @@
           <a:p>
             <a:fld id="{908607B5-E60D-4B4E-A941-993B6DE6A7EA}" type="datetimeFigureOut">
               <a:rPr lang="en-NG" smtClean="0"/>
-              <a:t>04/05/2026</a:t>
+              <a:t>12/05/2026</a:t>
             </a:fld>
             <a:endParaRPr lang="en-NG"/>
           </a:p>
@@ -2395,7 +2402,7 @@
           <a:p>
             <a:fld id="{908607B5-E60D-4B4E-A941-993B6DE6A7EA}" type="datetimeFigureOut">
               <a:rPr lang="en-NG" smtClean="0"/>
-              <a:t>04/05/2026</a:t>
+              <a:t>12/05/2026</a:t>
             </a:fld>
             <a:endParaRPr lang="en-NG"/>
           </a:p>
@@ -2684,7 +2691,7 @@
           <a:p>
             <a:fld id="{908607B5-E60D-4B4E-A941-993B6DE6A7EA}" type="datetimeFigureOut">
               <a:rPr lang="en-NG" smtClean="0"/>
-              <a:t>04/05/2026</a:t>
+              <a:t>12/05/2026</a:t>
             </a:fld>
             <a:endParaRPr lang="en-NG"/>
           </a:p>
@@ -2927,7 +2934,7 @@
           <a:p>
             <a:fld id="{908607B5-E60D-4B4E-A941-993B6DE6A7EA}" type="datetimeFigureOut">
               <a:rPr lang="en-NG" smtClean="0"/>
-              <a:t>04/05/2026</a:t>
+              <a:t>12/05/2026</a:t>
             </a:fld>
             <a:endParaRPr lang="en-NG"/>
           </a:p>
@@ -3386,7 +3393,7 @@
                 <a:latin typeface="Poppins" panose="00000500000000000000" pitchFamily="2" charset="0"/>
                 <a:cs typeface="Poppins" panose="00000500000000000000" pitchFamily="2" charset="0"/>
               </a:rPr>
-              <a:t>1/2</a:t>
+              <a:t>1/3</a:t>
             </a:r>
             <a:endParaRPr lang="en-NG" b="1" dirty="0">
               <a:solidFill>
@@ -3809,7 +3816,7 @@
                 <a:latin typeface="Poppins" panose="00000500000000000000" pitchFamily="2" charset="0"/>
                 <a:cs typeface="Poppins" panose="00000500000000000000" pitchFamily="2" charset="0"/>
               </a:rPr>
-              <a:t>2/2</a:t>
+              <a:t>2/3</a:t>
             </a:r>
             <a:endParaRPr lang="en-NG" b="1" dirty="0">
               <a:solidFill>
@@ -4193,6 +4200,403 @@
         <p:cNvPr id="1" name="">
           <a:extLst>
             <a:ext uri="{FF2B5EF4-FFF2-40B4-BE49-F238E27FC236}">
+              <a16:creationId xmlns:a16="http://schemas.microsoft.com/office/drawing/2014/main" id="{ABC524B5-ABDA-049D-786D-ECD98145E0BE}"/>
+            </a:ext>
+          </a:extLst>
+        </p:cNvPr>
+        <p:cNvGrpSpPr/>
+        <p:nvPr/>
+      </p:nvGrpSpPr>
+      <p:grpSpPr>
+        <a:xfrm>
+          <a:off x="0" y="0"/>
+          <a:ext cx="0" cy="0"/>
+          <a:chOff x="0" y="0"/>
+          <a:chExt cx="0" cy="0"/>
+        </a:xfrm>
+      </p:grpSpPr>
+      <p:sp>
+        <p:nvSpPr>
+          <p:cNvPr id="6" name="TextBox 5">
+            <a:extLst>
+              <a:ext uri="{FF2B5EF4-FFF2-40B4-BE49-F238E27FC236}">
+                <a16:creationId xmlns:a16="http://schemas.microsoft.com/office/drawing/2014/main" id="{23A7161A-3178-B654-C19D-15FF3D9CE8F2}"/>
+              </a:ext>
+            </a:extLst>
+          </p:cNvPr>
+          <p:cNvSpPr txBox="1"/>
+          <p:nvPr/>
+        </p:nvSpPr>
+        <p:spPr>
+          <a:xfrm>
+            <a:off x="997974" y="584902"/>
+            <a:ext cx="5343832" cy="369332"/>
+          </a:xfrm>
+          <a:prstGeom prst="rect">
+            <a:avLst/>
+          </a:prstGeom>
+          <a:noFill/>
+        </p:spPr>
+        <p:txBody>
+          <a:bodyPr wrap="square" rtlCol="0">
+            <a:spAutoFit/>
+          </a:bodyPr>
+          <a:lstStyle/>
+          <a:p>
+            <a:r>
+              <a:rPr lang="en-US" dirty="0">
+                <a:latin typeface="Bright Melody Personal Use Only" panose="02000500000000000000" pitchFamily="50" charset="0"/>
+              </a:rPr>
+              <a:t>Monthly Fuel Reminders 		</a:t>
+            </a:r>
+            <a:r>
+              <a:rPr lang="en-US" b="1" dirty="0">
+                <a:solidFill>
+                  <a:srgbClr val="EE0000"/>
+                </a:solidFill>
+                <a:latin typeface="Poppins" panose="00000500000000000000" pitchFamily="2" charset="0"/>
+                <a:cs typeface="Poppins" panose="00000500000000000000" pitchFamily="2" charset="0"/>
+              </a:rPr>
+              <a:t>3/3</a:t>
+            </a:r>
+            <a:endParaRPr lang="en-NG" b="1" dirty="0">
+              <a:solidFill>
+                <a:srgbClr val="EE0000"/>
+              </a:solidFill>
+              <a:latin typeface="Poppins" panose="00000500000000000000" pitchFamily="2" charset="0"/>
+              <a:cs typeface="Poppins" panose="00000500000000000000" pitchFamily="2" charset="0"/>
+            </a:endParaRPr>
+          </a:p>
+        </p:txBody>
+      </p:sp>
+      <p:sp>
+        <p:nvSpPr>
+          <p:cNvPr id="8" name="TextBox 7">
+            <a:extLst>
+              <a:ext uri="{FF2B5EF4-FFF2-40B4-BE49-F238E27FC236}">
+                <a16:creationId xmlns:a16="http://schemas.microsoft.com/office/drawing/2014/main" id="{031ADE7E-974A-3B49-D7DE-A8C00AD9603D}"/>
+              </a:ext>
+            </a:extLst>
+          </p:cNvPr>
+          <p:cNvSpPr txBox="1"/>
+          <p:nvPr/>
+        </p:nvSpPr>
+        <p:spPr>
+          <a:xfrm>
+            <a:off x="1039761" y="5913324"/>
+            <a:ext cx="10112477" cy="338554"/>
+          </a:xfrm>
+          <a:prstGeom prst="rect">
+            <a:avLst/>
+          </a:prstGeom>
+          <a:noFill/>
+        </p:spPr>
+        <p:txBody>
+          <a:bodyPr wrap="square" rtlCol="0">
+            <a:spAutoFit/>
+          </a:bodyPr>
+          <a:lstStyle/>
+          <a:p>
+            <a:pPr marL="285750" indent="-285750">
+              <a:buFont typeface="Wingdings" panose="05000000000000000000" pitchFamily="2" charset="2"/>
+              <a:buChar char="ü"/>
+            </a:pPr>
+            <a:r>
+              <a:rPr lang="en-US" sz="1600" dirty="0">
+                <a:solidFill>
+                  <a:schemeClr val="tx2">
+                    <a:lumMod val="75000"/>
+                    <a:lumOff val="25000"/>
+                  </a:schemeClr>
+                </a:solidFill>
+              </a:rPr>
+              <a:t>Email reminder for monthly fuel.</a:t>
+            </a:r>
+            <a:endParaRPr lang="en-NG" sz="1600" dirty="0">
+              <a:solidFill>
+                <a:schemeClr val="tx2">
+                  <a:lumMod val="75000"/>
+                  <a:lumOff val="25000"/>
+                </a:schemeClr>
+              </a:solidFill>
+              <a:latin typeface="Poppins" panose="00000500000000000000" pitchFamily="2" charset="0"/>
+              <a:cs typeface="Poppins" panose="00000500000000000000" pitchFamily="2" charset="0"/>
+            </a:endParaRPr>
+          </a:p>
+        </p:txBody>
+      </p:sp>
+      <p:cxnSp>
+        <p:nvCxnSpPr>
+          <p:cNvPr id="2" name="Straight Arrow Connector 1">
+            <a:extLst>
+              <a:ext uri="{FF2B5EF4-FFF2-40B4-BE49-F238E27FC236}">
+                <a16:creationId xmlns:a16="http://schemas.microsoft.com/office/drawing/2014/main" id="{74D344AE-EF1E-9955-6D8C-54D74C34057E}"/>
+              </a:ext>
+            </a:extLst>
+          </p:cNvPr>
+          <p:cNvCxnSpPr>
+            <a:cxnSpLocks/>
+          </p:cNvCxnSpPr>
+          <p:nvPr/>
+        </p:nvCxnSpPr>
+        <p:spPr>
+          <a:xfrm flipH="1" flipV="1">
+            <a:off x="4178710" y="4277032"/>
+            <a:ext cx="3215148" cy="1484691"/>
+          </a:xfrm>
+          <a:prstGeom prst="straightConnector1">
+            <a:avLst/>
+          </a:prstGeom>
+          <a:ln w="28575">
+            <a:solidFill>
+              <a:srgbClr val="EE0000"/>
+            </a:solidFill>
+            <a:tailEnd type="triangle"/>
+          </a:ln>
+        </p:spPr>
+        <p:style>
+          <a:lnRef idx="2">
+            <a:schemeClr val="accent1"/>
+          </a:lnRef>
+          <a:fillRef idx="0">
+            <a:schemeClr val="accent1"/>
+          </a:fillRef>
+          <a:effectRef idx="1">
+            <a:schemeClr val="accent1"/>
+          </a:effectRef>
+          <a:fontRef idx="minor">
+            <a:schemeClr val="tx1"/>
+          </a:fontRef>
+        </p:style>
+      </p:cxnSp>
+      <p:grpSp>
+        <p:nvGrpSpPr>
+          <p:cNvPr id="7" name="Group 6">
+            <a:extLst>
+              <a:ext uri="{FF2B5EF4-FFF2-40B4-BE49-F238E27FC236}">
+                <a16:creationId xmlns:a16="http://schemas.microsoft.com/office/drawing/2014/main" id="{27422601-5EE9-4534-9F51-A29F26B17B26}"/>
+              </a:ext>
+            </a:extLst>
+          </p:cNvPr>
+          <p:cNvGrpSpPr/>
+          <p:nvPr/>
+        </p:nvGrpSpPr>
+        <p:grpSpPr>
+          <a:xfrm>
+            <a:off x="0" y="0"/>
+            <a:ext cx="12192000" cy="456093"/>
+            <a:chOff x="0" y="0"/>
+            <a:chExt cx="12192000" cy="456093"/>
+          </a:xfrm>
+        </p:grpSpPr>
+        <p:sp>
+          <p:nvSpPr>
+            <p:cNvPr id="9" name="Rectangle 8">
+              <a:extLst>
+                <a:ext uri="{FF2B5EF4-FFF2-40B4-BE49-F238E27FC236}">
+                  <a16:creationId xmlns:a16="http://schemas.microsoft.com/office/drawing/2014/main" id="{706B6BC0-F6C8-9153-1C1B-07944FF20DD6}"/>
+                </a:ext>
+              </a:extLst>
+            </p:cNvPr>
+            <p:cNvSpPr/>
+            <p:nvPr/>
+          </p:nvSpPr>
+          <p:spPr>
+            <a:xfrm>
+              <a:off x="0" y="0"/>
+              <a:ext cx="12192000" cy="137652"/>
+            </a:xfrm>
+            <a:prstGeom prst="rect">
+              <a:avLst/>
+            </a:prstGeom>
+            <a:solidFill>
+              <a:srgbClr val="002060"/>
+            </a:solidFill>
+            <a:ln>
+              <a:noFill/>
+            </a:ln>
+          </p:spPr>
+          <p:style>
+            <a:lnRef idx="2">
+              <a:schemeClr val="accent1">
+                <a:shade val="15000"/>
+              </a:schemeClr>
+            </a:lnRef>
+            <a:fillRef idx="1">
+              <a:schemeClr val="accent1"/>
+            </a:fillRef>
+            <a:effectRef idx="0">
+              <a:schemeClr val="accent1"/>
+            </a:effectRef>
+            <a:fontRef idx="minor">
+              <a:schemeClr val="lt1"/>
+            </a:fontRef>
+          </p:style>
+          <p:txBody>
+            <a:bodyPr rtlCol="0" anchor="ctr"/>
+            <a:lstStyle/>
+            <a:p>
+              <a:pPr algn="ctr"/>
+              <a:endParaRPr lang="en-NG"/>
+            </a:p>
+          </p:txBody>
+        </p:sp>
+        <p:sp>
+          <p:nvSpPr>
+            <p:cNvPr id="11" name="Rectangle 10">
+              <a:extLst>
+                <a:ext uri="{FF2B5EF4-FFF2-40B4-BE49-F238E27FC236}">
+                  <a16:creationId xmlns:a16="http://schemas.microsoft.com/office/drawing/2014/main" id="{C285A842-7786-BAE5-6874-94961099CA6F}"/>
+                </a:ext>
+              </a:extLst>
+            </p:cNvPr>
+            <p:cNvSpPr/>
+            <p:nvPr/>
+          </p:nvSpPr>
+          <p:spPr>
+            <a:xfrm>
+              <a:off x="9114503" y="156209"/>
+              <a:ext cx="3077496" cy="137652"/>
+            </a:xfrm>
+            <a:prstGeom prst="rect">
+              <a:avLst/>
+            </a:prstGeom>
+            <a:solidFill>
+              <a:srgbClr val="002060"/>
+            </a:solidFill>
+            <a:ln>
+              <a:noFill/>
+            </a:ln>
+          </p:spPr>
+          <p:style>
+            <a:lnRef idx="2">
+              <a:schemeClr val="accent1">
+                <a:shade val="15000"/>
+              </a:schemeClr>
+            </a:lnRef>
+            <a:fillRef idx="1">
+              <a:schemeClr val="accent1"/>
+            </a:fillRef>
+            <a:effectRef idx="0">
+              <a:schemeClr val="accent1"/>
+            </a:effectRef>
+            <a:fontRef idx="minor">
+              <a:schemeClr val="lt1"/>
+            </a:fontRef>
+          </p:style>
+          <p:txBody>
+            <a:bodyPr rtlCol="0" anchor="ctr"/>
+            <a:lstStyle/>
+            <a:p>
+              <a:pPr algn="ctr"/>
+              <a:endParaRPr lang="en-NG"/>
+            </a:p>
+          </p:txBody>
+        </p:sp>
+        <p:sp>
+          <p:nvSpPr>
+            <p:cNvPr id="12" name="Rectangle 11">
+              <a:extLst>
+                <a:ext uri="{FF2B5EF4-FFF2-40B4-BE49-F238E27FC236}">
+                  <a16:creationId xmlns:a16="http://schemas.microsoft.com/office/drawing/2014/main" id="{CE17CF54-88D3-3D70-E91A-380F8E17CC91}"/>
+                </a:ext>
+              </a:extLst>
+            </p:cNvPr>
+            <p:cNvSpPr/>
+            <p:nvPr/>
+          </p:nvSpPr>
+          <p:spPr>
+            <a:xfrm>
+              <a:off x="9330812" y="318441"/>
+              <a:ext cx="2861187" cy="137652"/>
+            </a:xfrm>
+            <a:prstGeom prst="rect">
+              <a:avLst/>
+            </a:prstGeom>
+            <a:solidFill>
+              <a:srgbClr val="002060"/>
+            </a:solidFill>
+            <a:ln>
+              <a:noFill/>
+            </a:ln>
+          </p:spPr>
+          <p:style>
+            <a:lnRef idx="2">
+              <a:schemeClr val="accent1">
+                <a:shade val="15000"/>
+              </a:schemeClr>
+            </a:lnRef>
+            <a:fillRef idx="1">
+              <a:schemeClr val="accent1"/>
+            </a:fillRef>
+            <a:effectRef idx="0">
+              <a:schemeClr val="accent1"/>
+            </a:effectRef>
+            <a:fontRef idx="minor">
+              <a:schemeClr val="lt1"/>
+            </a:fontRef>
+          </p:style>
+          <p:txBody>
+            <a:bodyPr rtlCol="0" anchor="ctr"/>
+            <a:lstStyle/>
+            <a:p>
+              <a:pPr algn="ctr"/>
+              <a:endParaRPr lang="en-NG"/>
+            </a:p>
+          </p:txBody>
+        </p:sp>
+      </p:grpSp>
+      <p:pic>
+        <p:nvPicPr>
+          <p:cNvPr id="13" name="Picture 12">
+            <a:extLst>
+              <a:ext uri="{FF2B5EF4-FFF2-40B4-BE49-F238E27FC236}">
+                <a16:creationId xmlns:a16="http://schemas.microsoft.com/office/drawing/2014/main" id="{2EA106C3-38A7-27DA-9BC0-D5EDE7E0E837}"/>
+              </a:ext>
+            </a:extLst>
+          </p:cNvPr>
+          <p:cNvPicPr>
+            <a:picLocks noChangeAspect="1"/>
+          </p:cNvPicPr>
+          <p:nvPr/>
+        </p:nvPicPr>
+        <p:blipFill>
+          <a:blip r:embed="rId2"/>
+          <a:stretch>
+            <a:fillRect/>
+          </a:stretch>
+        </p:blipFill>
+        <p:spPr>
+          <a:xfrm>
+            <a:off x="668736" y="1105835"/>
+            <a:ext cx="9984515" cy="4655888"/>
+          </a:xfrm>
+          <a:prstGeom prst="rect">
+            <a:avLst/>
+          </a:prstGeom>
+        </p:spPr>
+      </p:pic>
+    </p:spTree>
+    <p:extLst>
+      <p:ext uri="{BB962C8B-B14F-4D97-AF65-F5344CB8AC3E}">
+        <p14:creationId xmlns:p14="http://schemas.microsoft.com/office/powerpoint/2010/main" val="2984884143"/>
+      </p:ext>
+    </p:extLst>
+  </p:cSld>
+  <p:clrMapOvr>
+    <a:masterClrMapping/>
+  </p:clrMapOvr>
+</p:sld>
+</file>
+
+<file path=ppt/slides/slide4.xml><?xml version="1.0" encoding="utf-8"?>
+<p:sld xmlns:a="http://schemas.openxmlformats.org/drawingml/2006/main" xmlns:r="http://schemas.openxmlformats.org/officeDocument/2006/relationships" xmlns:p="http://schemas.openxmlformats.org/presentationml/2006/main">
+  <p:cSld>
+    <p:spTree>
+      <p:nvGrpSpPr>
+        <p:cNvPr id="1" name="">
+          <a:extLst>
+            <a:ext uri="{FF2B5EF4-FFF2-40B4-BE49-F238E27FC236}">
               <a16:creationId xmlns:a16="http://schemas.microsoft.com/office/drawing/2014/main" id="{121C8E40-B764-A6DE-696E-CA5C8703112B}"/>
             </a:ext>
           </a:extLst>
@@ -4240,13 +4644,22 @@
               <a:rPr lang="en-US" dirty="0">
                 <a:latin typeface="Bright Melody Personal Use Only" panose="02000500000000000000" pitchFamily="50" charset="0"/>
               </a:rPr>
-              <a:t>Vehicle Licenses Expiry Reminder</a:t>
+              <a:t>Vehicle Licenses Expiry Reminder		</a:t>
+            </a:r>
+            <a:r>
+              <a:rPr lang="en-US" dirty="0">
+                <a:solidFill>
+                  <a:srgbClr val="EE0000"/>
+                </a:solidFill>
+                <a:latin typeface="Arial Black" panose="020B0A04020102020204" pitchFamily="34" charset="0"/>
+              </a:rPr>
+              <a:t>1/2</a:t>
             </a:r>
             <a:endParaRPr lang="en-NG" b="1" dirty="0">
               <a:solidFill>
                 <a:srgbClr val="EE0000"/>
               </a:solidFill>
-              <a:latin typeface="Poppins" panose="00000500000000000000" pitchFamily="2" charset="0"/>
+              <a:latin typeface="Arial Black" panose="020B0A04020102020204" pitchFamily="34" charset="0"/>
               <a:cs typeface="Poppins" panose="00000500000000000000" pitchFamily="2" charset="0"/>
             </a:endParaRPr>
           </a:p>
@@ -4685,6 +5098,369 @@
     <p:extLst>
       <p:ext uri="{BB962C8B-B14F-4D97-AF65-F5344CB8AC3E}">
         <p14:creationId xmlns:p14="http://schemas.microsoft.com/office/powerpoint/2010/main" val="1037815858"/>
+      </p:ext>
+    </p:extLst>
+  </p:cSld>
+  <p:clrMapOvr>
+    <a:masterClrMapping/>
+  </p:clrMapOvr>
+</p:sld>
+</file>
+
+<file path=ppt/slides/slide5.xml><?xml version="1.0" encoding="utf-8"?>
+<p:sld xmlns:a="http://schemas.openxmlformats.org/drawingml/2006/main" xmlns:r="http://schemas.openxmlformats.org/officeDocument/2006/relationships" xmlns:p="http://schemas.openxmlformats.org/presentationml/2006/main">
+  <p:cSld>
+    <p:spTree>
+      <p:nvGrpSpPr>
+        <p:cNvPr id="1" name="">
+          <a:extLst>
+            <a:ext uri="{FF2B5EF4-FFF2-40B4-BE49-F238E27FC236}">
+              <a16:creationId xmlns:a16="http://schemas.microsoft.com/office/drawing/2014/main" id="{97877642-BF2F-54FD-F082-1458DA92D43A}"/>
+            </a:ext>
+          </a:extLst>
+        </p:cNvPr>
+        <p:cNvGrpSpPr/>
+        <p:nvPr/>
+      </p:nvGrpSpPr>
+      <p:grpSpPr>
+        <a:xfrm>
+          <a:off x="0" y="0"/>
+          <a:ext cx="0" cy="0"/>
+          <a:chOff x="0" y="0"/>
+          <a:chExt cx="0" cy="0"/>
+        </a:xfrm>
+      </p:grpSpPr>
+      <p:sp>
+        <p:nvSpPr>
+          <p:cNvPr id="6" name="TextBox 5">
+            <a:extLst>
+              <a:ext uri="{FF2B5EF4-FFF2-40B4-BE49-F238E27FC236}">
+                <a16:creationId xmlns:a16="http://schemas.microsoft.com/office/drawing/2014/main" id="{91C2250A-BD5D-B10F-C160-862326BF12DE}"/>
+              </a:ext>
+            </a:extLst>
+          </p:cNvPr>
+          <p:cNvSpPr txBox="1"/>
+          <p:nvPr/>
+        </p:nvSpPr>
+        <p:spPr>
+          <a:xfrm>
+            <a:off x="997974" y="614398"/>
+            <a:ext cx="5343832" cy="369332"/>
+          </a:xfrm>
+          <a:prstGeom prst="rect">
+            <a:avLst/>
+          </a:prstGeom>
+          <a:noFill/>
+        </p:spPr>
+        <p:txBody>
+          <a:bodyPr wrap="square" rtlCol="0">
+            <a:spAutoFit/>
+          </a:bodyPr>
+          <a:lstStyle/>
+          <a:p>
+            <a:r>
+              <a:rPr lang="en-US" dirty="0">
+                <a:latin typeface="Bright Melody Personal Use Only" panose="02000500000000000000" pitchFamily="50" charset="0"/>
+              </a:rPr>
+              <a:t>Vehicle Licenses Expiry Reminder		</a:t>
+            </a:r>
+            <a:r>
+              <a:rPr lang="en-US" dirty="0">
+                <a:solidFill>
+                  <a:srgbClr val="EE0000"/>
+                </a:solidFill>
+                <a:latin typeface="Arial Black" panose="020B0A04020102020204" pitchFamily="34" charset="0"/>
+              </a:rPr>
+              <a:t> 2/2</a:t>
+            </a:r>
+            <a:endParaRPr lang="en-NG" b="1" dirty="0">
+              <a:solidFill>
+                <a:srgbClr val="EE0000"/>
+              </a:solidFill>
+              <a:latin typeface="Poppins" panose="00000500000000000000" pitchFamily="2" charset="0"/>
+              <a:cs typeface="Poppins" panose="00000500000000000000" pitchFamily="2" charset="0"/>
+            </a:endParaRPr>
+          </a:p>
+        </p:txBody>
+      </p:sp>
+      <p:sp>
+        <p:nvSpPr>
+          <p:cNvPr id="8" name="TextBox 7">
+            <a:extLst>
+              <a:ext uri="{FF2B5EF4-FFF2-40B4-BE49-F238E27FC236}">
+                <a16:creationId xmlns:a16="http://schemas.microsoft.com/office/drawing/2014/main" id="{F78B1ACB-EB5C-C601-FD73-86BE1583F045}"/>
+              </a:ext>
+            </a:extLst>
+          </p:cNvPr>
+          <p:cNvSpPr txBox="1"/>
+          <p:nvPr/>
+        </p:nvSpPr>
+        <p:spPr>
+          <a:xfrm>
+            <a:off x="1039761" y="5543707"/>
+            <a:ext cx="10112477" cy="338554"/>
+          </a:xfrm>
+          <a:prstGeom prst="rect">
+            <a:avLst/>
+          </a:prstGeom>
+          <a:noFill/>
+        </p:spPr>
+        <p:txBody>
+          <a:bodyPr wrap="square" rtlCol="0">
+            <a:spAutoFit/>
+          </a:bodyPr>
+          <a:lstStyle/>
+          <a:p>
+            <a:pPr marL="285750" indent="-285750">
+              <a:buFont typeface="Wingdings" panose="05000000000000000000" pitchFamily="2" charset="2"/>
+              <a:buChar char="ü"/>
+            </a:pPr>
+            <a:r>
+              <a:rPr lang="en-US" sz="1600" dirty="0">
+                <a:solidFill>
+                  <a:schemeClr val="tx2">
+                    <a:lumMod val="75000"/>
+                    <a:lumOff val="25000"/>
+                  </a:schemeClr>
+                </a:solidFill>
+              </a:rPr>
+              <a:t>Email reminder for expiring Fleet </a:t>
+            </a:r>
+            <a:r>
+              <a:rPr lang="en-US" sz="1600" dirty="0" err="1">
+                <a:solidFill>
+                  <a:schemeClr val="tx2">
+                    <a:lumMod val="75000"/>
+                    <a:lumOff val="25000"/>
+                  </a:schemeClr>
+                </a:solidFill>
+              </a:rPr>
+              <a:t>Licence</a:t>
+            </a:r>
+            <a:endParaRPr lang="en-NG" sz="1600" dirty="0">
+              <a:solidFill>
+                <a:schemeClr val="tx2">
+                  <a:lumMod val="75000"/>
+                  <a:lumOff val="25000"/>
+                </a:schemeClr>
+              </a:solidFill>
+              <a:latin typeface="Poppins" panose="00000500000000000000" pitchFamily="2" charset="0"/>
+              <a:cs typeface="Poppins" panose="00000500000000000000" pitchFamily="2" charset="0"/>
+            </a:endParaRPr>
+          </a:p>
+        </p:txBody>
+      </p:sp>
+      <p:pic>
+        <p:nvPicPr>
+          <p:cNvPr id="3" name="Picture 2">
+            <a:extLst>
+              <a:ext uri="{FF2B5EF4-FFF2-40B4-BE49-F238E27FC236}">
+                <a16:creationId xmlns:a16="http://schemas.microsoft.com/office/drawing/2014/main" id="{19ACE7FF-4D67-CEBE-303F-94E19F4D8F76}"/>
+              </a:ext>
+            </a:extLst>
+          </p:cNvPr>
+          <p:cNvPicPr>
+            <a:picLocks noChangeAspect="1"/>
+          </p:cNvPicPr>
+          <p:nvPr/>
+        </p:nvPicPr>
+        <p:blipFill>
+          <a:blip r:embed="rId2"/>
+          <a:stretch>
+            <a:fillRect/>
+          </a:stretch>
+        </p:blipFill>
+        <p:spPr>
+          <a:xfrm>
+            <a:off x="888756" y="1182003"/>
+            <a:ext cx="9737457" cy="4163431"/>
+          </a:xfrm>
+          <a:prstGeom prst="rect">
+            <a:avLst/>
+          </a:prstGeom>
+        </p:spPr>
+      </p:pic>
+      <p:grpSp>
+        <p:nvGrpSpPr>
+          <p:cNvPr id="16" name="Group 15">
+            <a:extLst>
+              <a:ext uri="{FF2B5EF4-FFF2-40B4-BE49-F238E27FC236}">
+                <a16:creationId xmlns:a16="http://schemas.microsoft.com/office/drawing/2014/main" id="{C3179A43-F4C0-F374-51AA-08C339A47AAC}"/>
+              </a:ext>
+            </a:extLst>
+          </p:cNvPr>
+          <p:cNvGrpSpPr/>
+          <p:nvPr/>
+        </p:nvGrpSpPr>
+        <p:grpSpPr>
+          <a:xfrm>
+            <a:off x="0" y="0"/>
+            <a:ext cx="12192000" cy="456093"/>
+            <a:chOff x="0" y="0"/>
+            <a:chExt cx="12192000" cy="456093"/>
+          </a:xfrm>
+        </p:grpSpPr>
+        <p:sp>
+          <p:nvSpPr>
+            <p:cNvPr id="17" name="Rectangle 16">
+              <a:extLst>
+                <a:ext uri="{FF2B5EF4-FFF2-40B4-BE49-F238E27FC236}">
+                  <a16:creationId xmlns:a16="http://schemas.microsoft.com/office/drawing/2014/main" id="{304BB4E9-C465-EF35-8D94-17A5DF65A696}"/>
+                </a:ext>
+              </a:extLst>
+            </p:cNvPr>
+            <p:cNvSpPr/>
+            <p:nvPr/>
+          </p:nvSpPr>
+          <p:spPr>
+            <a:xfrm>
+              <a:off x="0" y="0"/>
+              <a:ext cx="12192000" cy="137652"/>
+            </a:xfrm>
+            <a:prstGeom prst="rect">
+              <a:avLst/>
+            </a:prstGeom>
+            <a:solidFill>
+              <a:srgbClr val="002060"/>
+            </a:solidFill>
+            <a:ln>
+              <a:noFill/>
+            </a:ln>
+          </p:spPr>
+          <p:style>
+            <a:lnRef idx="2">
+              <a:schemeClr val="accent1">
+                <a:shade val="15000"/>
+              </a:schemeClr>
+            </a:lnRef>
+            <a:fillRef idx="1">
+              <a:schemeClr val="accent1"/>
+            </a:fillRef>
+            <a:effectRef idx="0">
+              <a:schemeClr val="accent1"/>
+            </a:effectRef>
+            <a:fontRef idx="minor">
+              <a:schemeClr val="lt1"/>
+            </a:fontRef>
+          </p:style>
+          <p:txBody>
+            <a:bodyPr rtlCol="0" anchor="ctr"/>
+            <a:lstStyle/>
+            <a:p>
+              <a:pPr algn="ctr"/>
+              <a:endParaRPr lang="en-NG"/>
+            </a:p>
+          </p:txBody>
+        </p:sp>
+        <p:sp>
+          <p:nvSpPr>
+            <p:cNvPr id="18" name="Rectangle 17">
+              <a:extLst>
+                <a:ext uri="{FF2B5EF4-FFF2-40B4-BE49-F238E27FC236}">
+                  <a16:creationId xmlns:a16="http://schemas.microsoft.com/office/drawing/2014/main" id="{831271FB-F6B2-729C-DDE3-B2EC7C9FE423}"/>
+                </a:ext>
+              </a:extLst>
+            </p:cNvPr>
+            <p:cNvSpPr/>
+            <p:nvPr/>
+          </p:nvSpPr>
+          <p:spPr>
+            <a:xfrm>
+              <a:off x="9114503" y="156209"/>
+              <a:ext cx="3077496" cy="137652"/>
+            </a:xfrm>
+            <a:prstGeom prst="rect">
+              <a:avLst/>
+            </a:prstGeom>
+            <a:solidFill>
+              <a:srgbClr val="002060"/>
+            </a:solidFill>
+            <a:ln>
+              <a:noFill/>
+            </a:ln>
+          </p:spPr>
+          <p:style>
+            <a:lnRef idx="2">
+              <a:schemeClr val="accent1">
+                <a:shade val="15000"/>
+              </a:schemeClr>
+            </a:lnRef>
+            <a:fillRef idx="1">
+              <a:schemeClr val="accent1"/>
+            </a:fillRef>
+            <a:effectRef idx="0">
+              <a:schemeClr val="accent1"/>
+            </a:effectRef>
+            <a:fontRef idx="minor">
+              <a:schemeClr val="lt1"/>
+            </a:fontRef>
+          </p:style>
+          <p:txBody>
+            <a:bodyPr rtlCol="0" anchor="ctr"/>
+            <a:lstStyle/>
+            <a:p>
+              <a:pPr algn="ctr"/>
+              <a:endParaRPr lang="en-NG"/>
+            </a:p>
+          </p:txBody>
+        </p:sp>
+        <p:sp>
+          <p:nvSpPr>
+            <p:cNvPr id="19" name="Rectangle 18">
+              <a:extLst>
+                <a:ext uri="{FF2B5EF4-FFF2-40B4-BE49-F238E27FC236}">
+                  <a16:creationId xmlns:a16="http://schemas.microsoft.com/office/drawing/2014/main" id="{54ABC6B3-4990-DA20-4A7C-3A7264CAD02C}"/>
+                </a:ext>
+              </a:extLst>
+            </p:cNvPr>
+            <p:cNvSpPr/>
+            <p:nvPr/>
+          </p:nvSpPr>
+          <p:spPr>
+            <a:xfrm>
+              <a:off x="9330812" y="318441"/>
+              <a:ext cx="2861187" cy="137652"/>
+            </a:xfrm>
+            <a:prstGeom prst="rect">
+              <a:avLst/>
+            </a:prstGeom>
+            <a:solidFill>
+              <a:srgbClr val="002060"/>
+            </a:solidFill>
+            <a:ln>
+              <a:noFill/>
+            </a:ln>
+          </p:spPr>
+          <p:style>
+            <a:lnRef idx="2">
+              <a:schemeClr val="accent1">
+                <a:shade val="15000"/>
+              </a:schemeClr>
+            </a:lnRef>
+            <a:fillRef idx="1">
+              <a:schemeClr val="accent1"/>
+            </a:fillRef>
+            <a:effectRef idx="0">
+              <a:schemeClr val="accent1"/>
+            </a:effectRef>
+            <a:fontRef idx="minor">
+              <a:schemeClr val="lt1"/>
+            </a:fontRef>
+          </p:style>
+          <p:txBody>
+            <a:bodyPr rtlCol="0" anchor="ctr"/>
+            <a:lstStyle/>
+            <a:p>
+              <a:pPr algn="ctr"/>
+              <a:endParaRPr lang="en-NG"/>
+            </a:p>
+          </p:txBody>
+        </p:sp>
+      </p:grpSp>
+    </p:spTree>
+    <p:extLst>
+      <p:ext uri="{BB962C8B-B14F-4D97-AF65-F5344CB8AC3E}">
+        <p14:creationId xmlns:p14="http://schemas.microsoft.com/office/powerpoint/2010/main" val="823351074"/>
       </p:ext>
     </p:extLst>
   </p:cSld>

</xml_diff>